<commit_message>
Update Feb 9 2026
</commit_message>
<xml_diff>
--- a/figures/ch7/natural history.pptx
+++ b/figures/ch7/natural history.pptx
@@ -197,7 +197,7 @@
           <a:p>
             <a:fld id="{E0D46A60-255F-684C-A684-CC10752AAD30}" type="datetimeFigureOut">
               <a:rPr lang="en-US" smtClean="0"/>
-              <a:t>1/26/26</a:t>
+              <a:t>2/8/26</a:t>
             </a:fld>
             <a:endParaRPr lang="en-US"/>
           </a:p>
@@ -698,7 +698,7 @@
           <a:p>
             <a:fld id="{19C17EAB-2A75-D149-9D07-4B5426996BDE}" type="datetimeFigureOut">
               <a:rPr lang="en-US" smtClean="0"/>
-              <a:t>1/26/26</a:t>
+              <a:t>2/8/26</a:t>
             </a:fld>
             <a:endParaRPr lang="en-US"/>
           </a:p>
@@ -898,7 +898,7 @@
           <a:p>
             <a:fld id="{19C17EAB-2A75-D149-9D07-4B5426996BDE}" type="datetimeFigureOut">
               <a:rPr lang="en-US" smtClean="0"/>
-              <a:t>1/26/26</a:t>
+              <a:t>2/8/26</a:t>
             </a:fld>
             <a:endParaRPr lang="en-US"/>
           </a:p>
@@ -1108,7 +1108,7 @@
           <a:p>
             <a:fld id="{19C17EAB-2A75-D149-9D07-4B5426996BDE}" type="datetimeFigureOut">
               <a:rPr lang="en-US" smtClean="0"/>
-              <a:t>1/26/26</a:t>
+              <a:t>2/8/26</a:t>
             </a:fld>
             <a:endParaRPr lang="en-US"/>
           </a:p>
@@ -1308,7 +1308,7 @@
           <a:p>
             <a:fld id="{19C17EAB-2A75-D149-9D07-4B5426996BDE}" type="datetimeFigureOut">
               <a:rPr lang="en-US" smtClean="0"/>
-              <a:t>1/26/26</a:t>
+              <a:t>2/8/26</a:t>
             </a:fld>
             <a:endParaRPr lang="en-US"/>
           </a:p>
@@ -1584,7 +1584,7 @@
           <a:p>
             <a:fld id="{19C17EAB-2A75-D149-9D07-4B5426996BDE}" type="datetimeFigureOut">
               <a:rPr lang="en-US" smtClean="0"/>
-              <a:t>1/26/26</a:t>
+              <a:t>2/8/26</a:t>
             </a:fld>
             <a:endParaRPr lang="en-US"/>
           </a:p>
@@ -1852,7 +1852,7 @@
           <a:p>
             <a:fld id="{19C17EAB-2A75-D149-9D07-4B5426996BDE}" type="datetimeFigureOut">
               <a:rPr lang="en-US" smtClean="0"/>
-              <a:t>1/26/26</a:t>
+              <a:t>2/8/26</a:t>
             </a:fld>
             <a:endParaRPr lang="en-US"/>
           </a:p>
@@ -2267,7 +2267,7 @@
           <a:p>
             <a:fld id="{19C17EAB-2A75-D149-9D07-4B5426996BDE}" type="datetimeFigureOut">
               <a:rPr lang="en-US" smtClean="0"/>
-              <a:t>1/26/26</a:t>
+              <a:t>2/8/26</a:t>
             </a:fld>
             <a:endParaRPr lang="en-US"/>
           </a:p>
@@ -2409,7 +2409,7 @@
           <a:p>
             <a:fld id="{19C17EAB-2A75-D149-9D07-4B5426996BDE}" type="datetimeFigureOut">
               <a:rPr lang="en-US" smtClean="0"/>
-              <a:t>1/26/26</a:t>
+              <a:t>2/8/26</a:t>
             </a:fld>
             <a:endParaRPr lang="en-US"/>
           </a:p>
@@ -2522,7 +2522,7 @@
           <a:p>
             <a:fld id="{19C17EAB-2A75-D149-9D07-4B5426996BDE}" type="datetimeFigureOut">
               <a:rPr lang="en-US" smtClean="0"/>
-              <a:t>1/26/26</a:t>
+              <a:t>2/8/26</a:t>
             </a:fld>
             <a:endParaRPr lang="en-US"/>
           </a:p>
@@ -2835,7 +2835,7 @@
           <a:p>
             <a:fld id="{19C17EAB-2A75-D149-9D07-4B5426996BDE}" type="datetimeFigureOut">
               <a:rPr lang="en-US" smtClean="0"/>
-              <a:t>1/26/26</a:t>
+              <a:t>2/8/26</a:t>
             </a:fld>
             <a:endParaRPr lang="en-US"/>
           </a:p>
@@ -3124,7 +3124,7 @@
           <a:p>
             <a:fld id="{19C17EAB-2A75-D149-9D07-4B5426996BDE}" type="datetimeFigureOut">
               <a:rPr lang="en-US" smtClean="0"/>
-              <a:t>1/26/26</a:t>
+              <a:t>2/8/26</a:t>
             </a:fld>
             <a:endParaRPr lang="en-US"/>
           </a:p>
@@ -3367,7 +3367,7 @@
           <a:p>
             <a:fld id="{19C17EAB-2A75-D149-9D07-4B5426996BDE}" type="datetimeFigureOut">
               <a:rPr lang="en-US" smtClean="0"/>
-              <a:t>1/26/26</a:t>
+              <a:t>2/8/26</a:t>
             </a:fld>
             <a:endParaRPr lang="en-US"/>
           </a:p>
@@ -4861,15 +4861,15 @@
         </p:nvPicPr>
         <p:blipFill rotWithShape="1">
           <a:blip r:embed="rId4"/>
-          <a:srcRect l="7842" t="1" r="-351" b="899"/>
+          <a:srcRect l="8755" t="2848" r="2403" b="4433"/>
           <a:stretch>
             <a:fillRect/>
           </a:stretch>
         </p:blipFill>
         <p:spPr>
           <a:xfrm flipH="1">
-            <a:off x="46549" y="4665832"/>
-            <a:ext cx="1111203" cy="983811"/>
+            <a:off x="79615" y="4694093"/>
+            <a:ext cx="1067167" cy="920466"/>
           </a:xfrm>
           <a:prstGeom prst="rect">
             <a:avLst/>

</xml_diff>